<commit_message>
Add Indian payment options: Google Pay, UPI apps, RuPay cards, Net Banking, and COD
</commit_message>
<xml_diff>
--- a/public/QuickCart-Project-Presentation.pptx
+++ b/public/QuickCart-Project-Presentation.pptx
@@ -11997,7 +11997,7 @@
                 <a:ea typeface="Calibri" pitchFamily="34" charset="-122"/>
                 <a:cs typeface="Calibri" pitchFamily="34" charset="-120"/>
               </a:rPr>
-              <a:t>Smart Checkout, Promo Engine &amp; Stripe Integration</a:t>
+              <a:t>Indian Multi-Payment Architecture &amp; Google Pay Integration</a:t>
             </a:r>
             <a:endParaRPr lang="en-US" sz="2600" dirty="0"/>
           </a:p>
@@ -12036,7 +12036,7 @@
                 <a:ea typeface="Calibri" pitchFamily="34" charset="-122"/>
                 <a:cs typeface="Calibri" pitchFamily="34" charset="-120"/>
               </a:rPr>
-              <a:t>Seamless order creation, real-time inventory stock deduction, and secure payment processing.</a:t>
+              <a:t>Seamless support for Google Pay (GPay), UPI, RuPay &amp; Visa Cards, Net Banking, and Cash on Delivery.</a:t>
             </a:r>
             <a:endParaRPr lang="en-US" sz="1300" dirty="0"/>
           </a:p>
@@ -12230,7 +12230,7 @@
                 <a:ea typeface="Calibri" pitchFamily="34" charset="-122"/>
                 <a:cs typeface="Calibri" pitchFamily="34" charset="-120"/>
               </a:rPr>
-              <a:t>Checkout &amp; Order Pipeline (checkout.html)</a:t>
+              <a:t>Multi-Payment Methods (checkout.html)</a:t>
             </a:r>
             <a:endParaRPr lang="en-US" sz="1650" dirty="0"/>
           </a:p>
@@ -12269,7 +12269,7 @@
                 <a:ea typeface="Calibri" pitchFamily="34" charset="-122"/>
                 <a:cs typeface="Calibri" pitchFamily="34" charset="-120"/>
               </a:rPr>
-              <a:t>1. Shipping &amp; Delivery Validation: Pre-fills saved customer address from User profile and validates street, city, state, ZIP, and country.</a:t>
+              <a:t>1. Google Pay &amp; UPI Apps: 1-click checkout via Google Pay, PhonePe, Paytm, BHIM, or any verified UPI handle (@okhdfcbank, @okaxis, @ybl).</a:t>
             </a:r>
             <a:endParaRPr lang="en-US" sz="1200" dirty="0"/>
           </a:p>
@@ -12308,7 +12308,7 @@
                 <a:ea typeface="Calibri" pitchFamily="34" charset="-122"/>
                 <a:cs typeface="Calibri" pitchFamily="34" charset="-120"/>
               </a:rPr>
-              <a:t>2. Promo Code Engine: Built-in support for promo code QUICK3D (15% instant discount) and automatic complimentary shipping across India on orders over ₹999.</a:t>
+              <a:t>2. Dynamic UPI QR Code: On-demand dynamic UPI QR generation with exact order total and instant scan from any mobile banking app.</a:t>
             </a:r>
             <a:endParaRPr lang="en-US" sz="1200" dirty="0"/>
           </a:p>
@@ -12347,7 +12347,7 @@
                 <a:ea typeface="Calibri" pitchFamily="34" charset="-122"/>
                 <a:cs typeface="Calibri" pitchFamily="34" charset="-120"/>
               </a:rPr>
-              <a:t>3. Atomic Stock Verification: Backend verifies product availability in MongoDB and automatically decrements stock upon order placement.</a:t>
+              <a:t>3. RuPay, Visa &amp; Cards: Real-time card brand detection, 16-digit spacing, MM/YY expiry auto-formatting, and CVV masking.</a:t>
             </a:r>
             <a:endParaRPr lang="en-US" sz="1200" dirty="0"/>
           </a:p>
@@ -12386,7 +12386,7 @@
                 <a:ea typeface="Calibri" pitchFamily="34" charset="-122"/>
                 <a:cs typeface="Calibri" pitchFamily="34" charset="-120"/>
               </a:rPr>
-              <a:t>4. Instant Order Confirmation: Generates a unique Order ID and redirects to the customer order history dashboard.</a:t>
+              <a:t>4. Net Banking &amp; COD: Instant access to 40+ Indian scheduled banks (SBI, HDFC, ICICI, Axis) plus Doorstep Cash on Delivery.</a:t>
             </a:r>
             <a:endParaRPr lang="en-US" sz="1200" dirty="0"/>
           </a:p>
@@ -12477,7 +12477,7 @@
                 <a:ea typeface="Calibri" pitchFamily="34" charset="-122"/>
                 <a:cs typeface="Calibri" pitchFamily="34" charset="-120"/>
               </a:rPr>
-              <a:t>Stripe Payment Architecture (routes/payment.js)</a:t>
+              <a:t>Order Settlement Pipeline (routes/orders.js)</a:t>
             </a:r>
             <a:endParaRPr lang="en-US" sz="1650" dirty="0"/>
           </a:p>
@@ -12516,7 +12516,7 @@
                 <a:ea typeface="Calibri" pitchFamily="34" charset="-122"/>
                 <a:cs typeface="Calibri" pitchFamily="34" charset="-120"/>
               </a:rPr>
-              <a:t>POST /api/payment/create-intent: Calculates order amount in cents and creates a secure Stripe PaymentIntent, returning clientSecret to the browser.</a:t>
+              <a:t>POST /api/orders: Records items, address, paymentMethod (gpay, upi, card, netbanking, cod), and paymentDetails.</a:t>
             </a:r>
             <a:endParaRPr lang="en-US" sz="1200" dirty="0"/>
           </a:p>
@@ -12555,7 +12555,7 @@
                 <a:ea typeface="Calibri" pitchFamily="34" charset="-122"/>
                 <a:cs typeface="Calibri" pitchFamily="34" charset="-120"/>
               </a:rPr>
-              <a:t>Stripe Elements Card UI: Mounts the PCI-compliant Stripe Card Element inside checkout.html with real-time card validation.</a:t>
+              <a:t>Atomic Stock Deduction: Verifies product availability and decrements available product stock atomically in MongoDB.</a:t>
             </a:r>
             <a:endParaRPr lang="en-US" sz="1200" dirty="0"/>
           </a:p>
@@ -12594,7 +12594,7 @@
                 <a:ea typeface="Calibri" pitchFamily="34" charset="-122"/>
                 <a:cs typeface="Calibri" pitchFamily="34" charset="-120"/>
               </a:rPr>
-              <a:t>POST /api/payment/webhook: Verifies cryptographic Stripe signature (stripe-signature header) using raw request body and updates Order paymentStatus to paid.</a:t>
+              <a:t>Indian Shipping Fee Engine: Automatically unlocks complimentary shipping across India for orders &gt;= ₹999 (₹99 under ₹999).</a:t>
             </a:r>
             <a:endParaRPr lang="en-US" sz="1200" dirty="0"/>
           </a:p>
@@ -12633,7 +12633,7 @@
                 <a:ea typeface="Calibri" pitchFamily="34" charset="-122"/>
                 <a:cs typeface="Calibri" pitchFamily="34" charset="-120"/>
               </a:rPr>
-              <a:t>Demo &amp; Development Fallback: Gracefully supports test checkout mode when running locally without live Stripe keys.</a:t>
+              <a:t>Downloadable Tax Invoice: Generates official GST/retail invoices with itemized totals, payment methods, and delivery tracking.</a:t>
             </a:r>
             <a:endParaRPr lang="en-US" sz="1200" dirty="0"/>
           </a:p>

</xml_diff>